<commit_message>
P3.19: checkpoint submission and UI audit
</commit_message>
<xml_diff>
--- a/docs/submission/DejaView-Track2-Presentation.pptx
+++ b/docs/submission/DejaView-Track2-Presentation.pptx
@@ -1008,12 +1008,12 @@
           </a:p>
           <a:p xmlns:a="http://schemas.openxmlformats.org/drawingml/2006/main">
             <a:r>
-              <a:t>Then name the limits in the small line: screen-only, macOS capture only with Windows not implemented, separate hardware checks, and the disclosed 2:37 video.</a:t>
-            </a:r>
-          </a:p>
-          <a:p xmlns:a="http://schemas.openxmlformats.org/drawingml/2006/main">
-            <a:r>
-              <a:t>Official submission guidance recommends a 3–5 minute demo. The accepted current video is 2:37 (157.2 seconds); it will be submitted as-is and will not be re-recorded.</a:t>
+              <a:t>Then name the limits in the small line: screen-only, macOS capture only with Windows not implemented, separate hardware checks, and the 3:15 English-primary demo.</a:t>
+            </a:r>
+          </a:p>
+          <a:p xmlns:a="http://schemas.openxmlformats.org/drawingml/2006/main">
+            <a:r>
+              <a:t>Official submission guidance recommends a 3–5 minute demo. The accepted original evidence cut remains unchanged at 2:37 (157.2 seconds); the 3:15.2 English-primary submission cut complies with that recommendation.</a:t>
             </a:r>
           </a:p>
           <a:p xmlns:a="http://schemas.openxmlformats.org/drawingml/2006/main">
@@ -5676,7 +5676,7 @@
                 <a:ea typeface="Helvetica Neue"/>
                 <a:cs typeface="Helvetica Neue"/>
               </a:rPr>
-              <a:t>screen-only today · macOS capture only; Windows not implemented · hardware checks separate · 2:37 demo disclosed</a:t>
+              <a:t>screen-only today · macOS capture only; Windows not implemented · hardware checks separate · 3:15 English-primary demo</a:t>
             </a:r>
           </a:p>
         </p:txBody>

</xml_diff>

<commit_message>
feat: finish P3.19 local evidence before CI accept
Sync the Track 2 PPTX to the 3:15 English-primary demo, pin Actions to
immutable SHAs, and record the live READY/recall/fallback/UI/clean-checkout
proof while keeping P3.19 doing until pushed CI is green.
</commit_message>
<xml_diff>
--- a/docs/submission/DejaView-Track2-Presentation.pptx
+++ b/docs/submission/DejaView-Track2-Presentation.pptx
@@ -1008,12 +1008,12 @@
           </a:p>
           <a:p xmlns:a="http://schemas.openxmlformats.org/drawingml/2006/main">
             <a:r>
-              <a:t>Then name the limits in the small line: screen-only, macOS capture only with Windows not implemented, separate hardware checks, and the disclosed 2:37 video.</a:t>
-            </a:r>
-          </a:p>
-          <a:p xmlns:a="http://schemas.openxmlformats.org/drawingml/2006/main">
-            <a:r>
-              <a:t>Official submission guidance recommends a 3–5 minute demo. The accepted current video is 2:37 (157.2 seconds); it will be submitted as-is and will not be re-recorded.</a:t>
+              <a:t>Then name the limits in the small line: screen-only, macOS capture only with Windows not implemented, separate hardware checks, and the 3:15 English-primary demo.</a:t>
+            </a:r>
+          </a:p>
+          <a:p xmlns:a="http://schemas.openxmlformats.org/drawingml/2006/main">
+            <a:r>
+              <a:t>Official submission guidance recommends a 3–5 minute demo. The immutable accepted evidence cut remains 2:37 (157.2 seconds); the English-primary submission cut is 3:15.2 and is within the official window.</a:t>
             </a:r>
           </a:p>
           <a:p xmlns:a="http://schemas.openxmlformats.org/drawingml/2006/main">
@@ -5676,7 +5676,7 @@
                 <a:ea typeface="Helvetica Neue"/>
                 <a:cs typeface="Helvetica Neue"/>
               </a:rPr>
-              <a:t>screen-only today · macOS capture only; Windows not implemented · hardware checks separate · 2:37 demo disclosed</a:t>
+              <a:t>screen-only today · macOS capture only; Windows not implemented · hardware checks separate · 3:15 English-primary demo</a:t>
             </a:r>
           </a:p>
         </p:txBody>

</xml_diff>